<commit_message>
Sped up recipe details with LiteRT-LM 0.17.1 and a leaner prompt, tuned the demo list and docs
</commit_message>
<xml_diff>
--- a/AI On-Device - ita.pptx
+++ b/AI On-Device - ita.pptx
@@ -7031,61 +7031,13 @@
           <a:p>
             <a:r>
               <a:rPr lang="it-IT" noProof="0" dirty="0"/>
-              <a:t>[Prima del talk: telefono in mirroring, modalità aereo ATTIVA, dispensa vuota (“Your </a:t>
-            </a:r>
-            <a:r>
-              <a:rPr lang="it-IT" noProof="0" dirty="0" err="1"/>
-              <a:t>pantry</a:t>
-            </a:r>
-            <a:r>
-              <a:rPr lang="it-IT" noProof="0" dirty="0"/>
-              <a:t> </a:t>
-            </a:r>
-            <a:r>
-              <a:rPr lang="it-IT" noProof="0" dirty="0" err="1"/>
-              <a:t>is</a:t>
-            </a:r>
-            <a:r>
-              <a:rPr lang="it-IT" noProof="0" dirty="0"/>
-              <a:t> </a:t>
-            </a:r>
-            <a:r>
-              <a:rPr lang="it-IT" noProof="0" dirty="0" err="1"/>
-              <a:t>empty</a:t>
-            </a:r>
-            <a:r>
-              <a:rPr lang="it-IT" noProof="0" dirty="0"/>
-              <a:t>”, eventualmente “Clear </a:t>
-            </a:r>
-            <a:r>
-              <a:rPr lang="it-IT" noProof="0" dirty="0" err="1"/>
-              <a:t>all</a:t>
-            </a:r>
-            <a:r>
-              <a:rPr lang="it-IT" noProof="0" dirty="0"/>
-              <a:t>”), Gemma già pronto (niente banner “</a:t>
-            </a:r>
-            <a:r>
-              <a:rPr lang="it-IT" noProof="0" dirty="0" err="1"/>
-              <a:t>Preparing</a:t>
-            </a:r>
-            <a:r>
-              <a:rPr lang="it-IT" noProof="0" dirty="0"/>
-              <a:t> Gemma 4 E2B…”). Tenere in galleria una foto di frigo e una di dispensa già testate, da usare con “Pick from </a:t>
-            </a:r>
-            <a:r>
-              <a:rPr lang="it-IT" noProof="0" dirty="0" err="1"/>
-              <a:t>gallery</a:t>
-            </a:r>
-            <a:r>
-              <a:rPr lang="it-IT" noProof="0" dirty="0"/>
-              <a:t>”. Video di backup pronto.]</a:t>
-            </a:r>
-          </a:p>
-          <a:p>
-            <a:r>
-              <a:rPr lang="it-IT" noProof="0" dirty="0"/>
-              <a:t>[Nota: le label dell’app sono in inglese, le nominiamo così come sono.] -&gt; (da tradurre in ita, ora l’app è in ita)</a:t>
+              <a:t>[Prima del talk: telefono in mirroring, modalità aereo ATTIVA, dispensa vuota (“La tua dispensa è vuota”, eventualmente “Svuota tutto”), Gemma già pronto (niente banner “Preparazione di Gemma 4 E2B…”). Tenere in galleria una foto di frigo e una di dispensa già testate, da scegliere con il pulsante della galleria in basso a sinistra. Video di backup pronto: demo.mp4.]</a:t>
+            </a:r>
+          </a:p>
+          <a:p>
+            <a:r>
+              <a:rPr lang="it-IT" noProof="0" dirty="0"/>
+              <a:t>[Tempi, dal video: ogni foto si analizza in 20-25 secondi, le 4 ricette arrivano in meno di un minuto, la ricetta completa in poco più di 2 minuti.]</a:t>
             </a:r>
           </a:p>
           <a:p>
@@ -7106,93 +7058,37 @@
           <a:p>
             <a:r>
               <a:rPr lang="it-IT" noProof="0" dirty="0"/>
-              <a:t>[tocca “Scan </a:t>
-            </a:r>
-            <a:r>
-              <a:rPr lang="it-IT" noProof="0" dirty="0" err="1"/>
-              <a:t>my</a:t>
-            </a:r>
-            <a:r>
-              <a:rPr lang="it-IT" noProof="0" dirty="0"/>
-              <a:t> </a:t>
-            </a:r>
-            <a:r>
-              <a:rPr lang="it-IT" noProof="0" dirty="0" err="1"/>
-              <a:t>fridge</a:t>
-            </a:r>
-            <a:r>
-              <a:rPr lang="it-IT" noProof="0" dirty="0"/>
-              <a:t>”, chip “Fridge” selezionato, scatta la foto o usa “Pick from </a:t>
-            </a:r>
-            <a:r>
-              <a:rPr lang="it-IT" noProof="0" dirty="0" err="1"/>
-              <a:t>gallery</a:t>
-            </a:r>
-            <a:r>
-              <a:rPr lang="it-IT" noProof="0" dirty="0"/>
-              <a:t>”]</a:t>
-            </a:r>
-          </a:p>
-          <a:p>
-            <a:r>
-              <a:rPr lang="it-IT" noProof="0" dirty="0"/>
-              <a:t>Scelgo “Fridge”, inquadro il frigo e scatto.</a:t>
-            </a:r>
-          </a:p>
-          <a:p>
-            <a:endParaRPr lang="it-IT" noProof="0" dirty="0"/>
-          </a:p>
-          <a:p>
-            <a:r>
-              <a:rPr lang="it-IT" noProof="0" dirty="0"/>
-              <a:t>[sullo schermo “</a:t>
-            </a:r>
-            <a:r>
-              <a:rPr lang="it-IT" noProof="0" dirty="0" err="1"/>
-              <a:t>Detecting</a:t>
-            </a:r>
-            <a:r>
-              <a:rPr lang="it-IT" noProof="0" dirty="0"/>
-              <a:t> </a:t>
-            </a:r>
-            <a:r>
-              <a:rPr lang="it-IT" noProof="0" dirty="0" err="1"/>
-              <a:t>ingredients</a:t>
-            </a:r>
-            <a:r>
-              <a:rPr lang="it-IT" noProof="0" dirty="0"/>
-              <a:t> on-device…”]</a:t>
-            </a:r>
-          </a:p>
-          <a:p>
-            <a:r>
-              <a:rPr lang="it-IT" noProof="0" dirty="0"/>
-              <a:t>Quello che sta succedendo adesso è la parte di percezione: l’app sta capendo quali ingredienti ci sono nella foto. Nel corso del talk vi spieghiamo perché questa parte, all’inizio, ci metteva minuti, e come l’abbiamo portata a pochi secondi.</a:t>
-            </a:r>
-          </a:p>
-          <a:p>
-            <a:endParaRPr lang="it-IT" noProof="0" dirty="0"/>
-          </a:p>
-          <a:p>
-            <a:r>
-              <a:rPr lang="it-IT" noProof="0" dirty="0"/>
-              <a:t>[si apre il foglio “</a:t>
-            </a:r>
-            <a:r>
-              <a:rPr lang="it-IT" noProof="0" dirty="0" err="1"/>
-              <a:t>Ingredients</a:t>
-            </a:r>
-            <a:r>
-              <a:rPr lang="it-IT" noProof="0" dirty="0"/>
-              <a:t> </a:t>
-            </a:r>
-            <a:r>
-              <a:rPr lang="it-IT" noProof="0" dirty="0" err="1"/>
-              <a:t>detected</a:t>
-            </a:r>
-            <a:r>
-              <a:rPr lang="it-IT" noProof="0" dirty="0"/>
-              <a:t>”]</a:t>
+              <a:t>[tocca “Scansiona il frigo”, “Frigo” già selezionato, scatta la foto o la sceglie dalla galleria]</a:t>
+            </a:r>
+          </a:p>
+          <a:p>
+            <a:r>
+              <a:rPr lang="it-IT" noProof="0" dirty="0"/>
+              <a:t>Scelgo “Frigo”, inquadro il frigo e scatto.</a:t>
+            </a:r>
+          </a:p>
+          <a:p>
+            <a:endParaRPr lang="it-IT" noProof="0" dirty="0"/>
+          </a:p>
+          <a:p>
+            <a:r>
+              <a:rPr lang="it-IT" noProof="0" dirty="0"/>
+              <a:t>[sullo schermo “Riconosco gli ingredienti”: sulla foto si accendono le zone che sta analizzando (“Zone analizzate”) e gli ingredienti compaiono man mano]</a:t>
+            </a:r>
+          </a:p>
+          <a:p>
+            <a:r>
+              <a:rPr lang="it-IT" noProof="0" dirty="0"/>
+              <a:t>Quello che sta succedendo adesso è la parte di percezione: l’app sta capendo quali ingredienti ci sono nella foto, zona per zona, e li vedete comparire appena li trova. Nel corso del talk vi spieghiamo perché questa parte, all’inizio, ci metteva minuti, e come l’abbiamo portata a pochi secondi.</a:t>
+            </a:r>
+          </a:p>
+          <a:p>
+            <a:endParaRPr lang="it-IT" noProof="0" dirty="0"/>
+          </a:p>
+          <a:p>
+            <a:r>
+              <a:rPr lang="it-IT" noProof="0" dirty="0"/>
+              <a:t>[si apre il foglio “N ingredienti trovati”]</a:t>
             </a:r>
           </a:p>
           <a:p>
@@ -7207,7 +7103,7 @@
           <a:p>
             <a:r>
               <a:rPr lang="it-IT" noProof="0" dirty="0"/>
-              <a:t>[indica la riga “Engine: … · 100% on-device” in fondo]</a:t>
+              <a:t>[indica la riga in alto “MobileCLIP-S2 zero-shot · LiteRT · on device”]</a:t>
             </a:r>
           </a:p>
           <a:p>
@@ -7222,93 +7118,37 @@
           <a:p>
             <a:r>
               <a:rPr lang="it-IT" noProof="0" dirty="0"/>
-              <a:t>[tocca “Scan </a:t>
-            </a:r>
-            <a:r>
-              <a:rPr lang="it-IT" noProof="0" dirty="0" err="1"/>
-              <a:t>another</a:t>
-            </a:r>
-            <a:r>
-              <a:rPr lang="it-IT" noProof="0" dirty="0"/>
-              <a:t>”, seleziona “Pantry”, scatta]</a:t>
-            </a:r>
-          </a:p>
-          <a:p>
-            <a:r>
-              <a:rPr lang="it-IT" noProof="0" dirty="0"/>
-              <a:t>Faccio lo stesso con la dispensa. Le due scansioni si sommano.</a:t>
-            </a:r>
-          </a:p>
-          <a:p>
-            <a:endParaRPr lang="it-IT" noProof="0" dirty="0"/>
-          </a:p>
-          <a:p>
-            <a:r>
-              <a:rPr lang="it-IT" noProof="0" dirty="0"/>
-              <a:t>[tocca “</a:t>
-            </a:r>
-            <a:r>
-              <a:rPr lang="it-IT" noProof="0" dirty="0" err="1"/>
-              <a:t>Add</a:t>
-            </a:r>
-            <a:r>
-              <a:rPr lang="it-IT" noProof="0" dirty="0"/>
-              <a:t> to </a:t>
-            </a:r>
-            <a:r>
-              <a:rPr lang="it-IT" noProof="0" dirty="0" err="1"/>
-              <a:t>pantry</a:t>
-            </a:r>
-            <a:r>
-              <a:rPr lang="it-IT" noProof="0" dirty="0"/>
-              <a:t> (</a:t>
-            </a:r>
-            <a:r>
-              <a:rPr lang="it-IT" noProof="0" dirty="0" err="1"/>
-              <a:t>N</a:t>
-            </a:r>
-            <a:r>
-              <a:rPr lang="it-IT" noProof="0" dirty="0"/>
-              <a:t>)”, torna alla home con l’inventario]</a:t>
-            </a:r>
-          </a:p>
-          <a:p>
-            <a:r>
-              <a:rPr lang="it-IT" noProof="0" dirty="0"/>
-              <a:t>Aggiungo tutto alla dispensa. E questo è l’inventario, salvato in locale sul telefono.</a:t>
-            </a:r>
-          </a:p>
-          <a:p>
-            <a:endParaRPr lang="it-IT" noProof="0" dirty="0"/>
-          </a:p>
-          <a:p>
-            <a:r>
-              <a:rPr lang="it-IT" noProof="0" dirty="0"/>
-              <a:t>[tocca “</a:t>
-            </a:r>
-            <a:r>
-              <a:rPr lang="it-IT" noProof="0" dirty="0" err="1"/>
-              <a:t>What</a:t>
-            </a:r>
-            <a:r>
-              <a:rPr lang="it-IT" noProof="0" dirty="0"/>
-              <a:t> can I </a:t>
-            </a:r>
-            <a:r>
-              <a:rPr lang="it-IT" noProof="0" dirty="0" err="1"/>
-              <a:t>cook</a:t>
-            </a:r>
-            <a:r>
-              <a:rPr lang="it-IT" noProof="0" dirty="0"/>
-              <a:t>? (</a:t>
-            </a:r>
-            <a:r>
-              <a:rPr lang="it-IT" noProof="0" dirty="0" err="1"/>
-              <a:t>N</a:t>
-            </a:r>
-            <a:r>
-              <a:rPr lang="it-IT" noProof="0" dirty="0"/>
-              <a:t>)”]</a:t>
+              <a:t>[tocca “Altra scansione”, seleziona “Dispensa”, scatta o sceglie la foto della dispensa]</a:t>
+            </a:r>
+          </a:p>
+          <a:p>
+            <a:r>
+              <a:rPr lang="it-IT" noProof="0" dirty="0"/>
+              <a:t>Faccio lo stesso con la dispensa. Le due scansioni si sommano. [il foglio ora conta gli ingredienti di tutte e due]</a:t>
+            </a:r>
+          </a:p>
+          <a:p>
+            <a:endParaRPr lang="it-IT" noProof="0" dirty="0"/>
+          </a:p>
+          <a:p>
+            <a:r>
+              <a:rPr lang="it-IT" noProof="0" dirty="0"/>
+              <a:t>[tocca “Aggiungi a frigo e dispensa (N)”, torna a “La tua cucina” con frigo e dispensa]</a:t>
+            </a:r>
+          </a:p>
+          <a:p>
+            <a:r>
+              <a:rPr lang="it-IT" noProof="0" dirty="0"/>
+              <a:t>Aggiungo tutto. E questo è l’inventario, salvato in locale sul telefono.</a:t>
+            </a:r>
+          </a:p>
+          <a:p>
+            <a:endParaRPr lang="it-IT" noProof="0" dirty="0"/>
+          </a:p>
+          <a:p>
+            <a:r>
+              <a:rPr lang="it-IT" noProof="0" dirty="0"/>
+              <a:t>[tocca “Cosa posso cucinare? (N)”]</a:t>
             </a:r>
           </a:p>
           <a:p>
@@ -7323,7 +7163,7 @@
           <a:p>
             <a:r>
               <a:rPr lang="it-IT" noProof="0" dirty="0"/>
-              <a:t>[mentre genera]</a:t>
+              <a:t>[schermata “Genero le ricette”, poi le ricette arrivano una alla volta (“Ricetta 2 di 4”…)]</a:t>
             </a:r>
           </a:p>
           <a:p>
@@ -7338,85 +7178,37 @@
           <a:p>
             <a:r>
               <a:rPr lang="it-IT" noProof="0" dirty="0"/>
-              <a:t>[appare la lista di ricette]</a:t>
-            </a:r>
-          </a:p>
-          <a:p>
-            <a:r>
-              <a:rPr lang="it-IT" noProof="0" dirty="0"/>
-              <a:t>Ecco cinque idee per la cena, con tempo e difficoltà. Sono ordinate in base a quanto usano quello che ho davvero: quelle che richiedono di comprare qualcosa finiscono in fondo, e l’app mi dice cosa mi manca. [indicare “</a:t>
-            </a:r>
-            <a:r>
-              <a:rPr lang="it-IT" noProof="0" dirty="0" err="1"/>
-              <a:t>You’ll</a:t>
-            </a:r>
-            <a:r>
-              <a:rPr lang="it-IT" noProof="0" dirty="0"/>
-              <a:t> </a:t>
-            </a:r>
-            <a:r>
-              <a:rPr lang="it-IT" noProof="0" dirty="0" err="1"/>
-              <a:t>also</a:t>
-            </a:r>
-            <a:r>
-              <a:rPr lang="it-IT" noProof="0" dirty="0"/>
-              <a:t> </a:t>
-            </a:r>
-            <a:r>
-              <a:rPr lang="it-IT" noProof="0" dirty="0" err="1"/>
-              <a:t>need</a:t>
-            </a:r>
-            <a:r>
-              <a:rPr lang="it-IT" noProof="0" dirty="0"/>
-              <a:t>” su una ricetta]</a:t>
-            </a:r>
-          </a:p>
-          <a:p>
-            <a:endParaRPr lang="it-IT" noProof="0" dirty="0"/>
-          </a:p>
-          <a:p>
-            <a:r>
-              <a:rPr lang="it-IT" noProof="0" dirty="0"/>
-              <a:t>[apre una ricetta: “Writing the </a:t>
-            </a:r>
-            <a:r>
-              <a:rPr lang="it-IT" noProof="0" dirty="0" err="1"/>
-              <a:t>instructions</a:t>
-            </a:r>
-            <a:r>
-              <a:rPr lang="it-IT" noProof="0" dirty="0"/>
-              <a:t> on-device…”]</a:t>
-            </a:r>
-          </a:p>
-          <a:p>
-            <a:r>
-              <a:rPr lang="it-IT" noProof="0" dirty="0"/>
-              <a:t>Apro questa. I passaggi non esistevano finché non l’ho aperta: li sta scrivendo adesso, qui sul telefono. [compaiono “</a:t>
-            </a:r>
-            <a:r>
-              <a:rPr lang="it-IT" noProof="0" dirty="0" err="1"/>
-              <a:t>Instructions</a:t>
-            </a:r>
-            <a:r>
-              <a:rPr lang="it-IT" noProof="0" dirty="0"/>
-              <a:t>” e “</a:t>
-            </a:r>
-            <a:r>
-              <a:rPr lang="it-IT" noProof="0" dirty="0" err="1"/>
-              <a:t>Variants</a:t>
-            </a:r>
-            <a:r>
-              <a:rPr lang="it-IT" noProof="0" dirty="0"/>
-              <a:t>”] Ecco istruzioni e varianti.</a:t>
-            </a:r>
-          </a:p>
-          <a:p>
-            <a:endParaRPr lang="it-IT" noProof="0" dirty="0"/>
-          </a:p>
-          <a:p>
-            <a:br>
-              <a:rPr lang="it-IT" noProof="0" dirty="0"/>
-            </a:br>
+              <a:t>[appare la lista “Ecco cosa puoi cucinare”]</a:t>
+            </a:r>
+          </a:p>
+          <a:p>
+            <a:r>
+              <a:rPr lang="it-IT" noProof="0" dirty="0"/>
+              <a:t>Ecco quattro idee per la cena, con tempo e difficoltà. Sono ordinate in base a quanto usano quello che ho davvero: quelle che richiedono di comprare qualcosa finiscono in fondo, e l’app mi dice cosa mi manca. [se una ricetta mostra “Mancano: …”, indicarlo] E se non mi convincono, “Altre ricette” me ne propone altre quattro.</a:t>
+            </a:r>
+          </a:p>
+          <a:p>
+            <a:endParaRPr lang="it-IT" noProof="0" dirty="0"/>
+          </a:p>
+          <a:p>
+            <a:r>
+              <a:rPr lang="it-IT" noProof="0" dirty="0"/>
+              <a:t>[apre una ricetta: in basso “Genero la ricetta…”]</a:t>
+            </a:r>
+          </a:p>
+          <a:p>
+            <a:r>
+              <a:rPr lang="it-IT" noProof="0" dirty="0"/>
+              <a:t>Apro questa. Quantità e passaggi non esistevano finché non l’ho aperta: li sta scrivendo adesso, qui sul telefono. [compaiono le quantità, poi i passaggi del “Procedimento” uno alla volta, poi le “Varianti”. Non aspettare la fine: la ricetta completa ci mette poco più di 2 minuti]</a:t>
+            </a:r>
+          </a:p>
+          <a:p>
+            <a:endParaRPr lang="it-IT" noProof="0" dirty="0"/>
+          </a:p>
+          <a:p>
+            <a:endParaRPr lang="it-IT" noProof="0" dirty="0"/>
+          </a:p>
+          <a:p>
             <a:r>
               <a:rPr lang="it-IT" noProof="0" dirty="0"/>
               <a:t>E vi ricordo: modalità aereo. Nessuna chiamata di rete. Nessun costo per chiamata. Nessuna foto di questo frigo è finita su un server.</a:t>
@@ -7426,24 +7218,24 @@
             <a:endParaRPr lang="it-IT" noProof="0" dirty="0"/>
           </a:p>
           <a:p>
-            <a:br>
-              <a:rPr lang="it-IT" noProof="0" dirty="0"/>
-            </a:br>
+            <a:endParaRPr lang="it-IT" noProof="0" dirty="0"/>
+          </a:p>
+          <a:p>
             <a:r>
               <a:rPr lang="it-IT" noProof="0" dirty="0"/>
               <a:t>Questa è AI Pantry. Ora vi raccontiamo come ci siamo arrivati, e perché ci abbiamo messo più tentativi del previsto. [torna alle slide]</a:t>
             </a:r>
           </a:p>
           <a:p>
-            <a:br>
-              <a:rPr lang="it-IT" noProof="0" dirty="0"/>
-            </a:br>
-            <a:endParaRPr lang="it-IT" noProof="0" dirty="0"/>
-          </a:p>
-          <a:p>
-            <a:r>
-              <a:rPr lang="it-IT" noProof="0" dirty="0"/>
-              <a:t>[PIANO B: se la demo si blocca → “La demo on-device ha deciso di essere molto on-device” → far partire il video di backup e commentarlo con lo stesso script.]</a:t>
+            <a:endParaRPr lang="it-IT" noProof="0" dirty="0"/>
+          </a:p>
+          <a:p>
+            <a:endParaRPr lang="it-IT" noProof="0" dirty="0"/>
+          </a:p>
+          <a:p>
+            <a:r>
+              <a:rPr lang="it-IT" noProof="0" dirty="0"/>
+              <a:t>[PIANO B: se la demo si blocca → “La demo on-device ha deciso di essere molto on-device” → far partire il video di backup (demo.mp4) e commentarlo con lo stesso script. Nel video il telefono non è in modalità aereo: saltare le frasi sulla modalità aereo. La ricetta completa occupa gli ultimi 2 minuti del video: si può mandare avanti.]</a:t>
             </a:r>
           </a:p>
         </p:txBody>

</xml_diff>

<commit_message>
Wrote recipes with Gemini Nano 4 where the phone has it, falling back to Gemma on LiteRT-LM
</commit_message>
<xml_diff>
--- a/AI On-Device - ita.pptx
+++ b/AI On-Device - ita.pptx
@@ -46,7 +46,7 @@
       <p:boldItalic r:id="rId32"/>
     </p:embeddedFont>
     <p:embeddedFont>
-      <p:font typeface="Geist" pitchFamily="2" charset="77"/>
+      <p:font typeface="Geist"/>
       <p:regular r:id="rId33"/>
     </p:embeddedFont>
     <p:embeddedFont>
@@ -2683,7 +2683,7 @@
           <a:p>
             <a:r>
               <a:rPr lang="it-IT" noProof="0" dirty="0"/>
-              <a:t>Viene aggiornato tramite Google Play services, e a seconda del dispositivo può essere nano v2 o v3.</a:t>
+              <a:t>Viene aggiornato tramite Google Play services, e a seconda del dispositivo può essere nano v3 o v4.</a:t>
             </a:r>
           </a:p>
           <a:p>
@@ -9795,7 +9795,7 @@
                 <a:ea typeface="Helvetica Neue" panose="02000503000000020004" pitchFamily="2" charset="0"/>
                 <a:cs typeface="Helvetica Neue" panose="02000503000000020004" pitchFamily="2" charset="0"/>
               </a:rPr>
-              <a:t>Aggiornato da Google Play services: nano-v2 / nano-v3 in base al dispositivo, migliora senza che tu rilasci nulla</a:t>
+              <a:t>Aggiornato da Google Play services: nano-v3 / nano-v4 in base al dispositivo, migliora senza che tu rilasci nulla</a:t>
             </a:r>
           </a:p>
         </p:txBody>

</xml_diff>